<commit_message>
Align CMO deck to use-case MCP/API recommendation
Update ask, architecture, recommendation, decisions, HTML viewer,
and speaker notes: approve MCP or API by use case; knowledge domain
is a separate goal; content/assistant live only in Insightful today.

Co-authored-by: ChristophToth <ChristophToth@users.noreply.github.com>
</commit_message>
<xml_diff>
--- a/presentations/cmo-insightful-ai-access/CMO_Insightful_AI_Access_Recommendation.pptx
+++ b/presentations/cmo-insightful-ai-access/CMO_Insightful_AI_Access_Recommendation.pptx
@@ -3588,7 +3588,7 @@
                 </a:solidFill>
                 <a:latin typeface="Arial"/>
               </a:rPr>
-              <a:t>Sign on for MCP as the primary path for agent builders; enable API alongside it for custom AI tools. Advance the Ask AT&amp;T knowledge domain as a strategic side investment — not the near-term demand solution.</a:t>
+              <a:t>Approve MCP or API access to live Insightful based on use case. Treat the Ask AT&amp;T knowledge domain as a separate goal — not the near-term demand solution.</a:t>
             </a:r>
           </a:p>
         </p:txBody>
@@ -3627,7 +3627,7 @@
                 </a:solidFill>
                 <a:latin typeface="Arial"/>
               </a:rPr>
-              <a:t>Why MCP first for agents: it is the cleanest way for AI tools to call Insightful as a governed capability — search, retrieve, cite — without each team inventing a private pipeline.</a:t>
+              <a:t>Today: content and the AI assistant exist only inside Insightful (Stravito, AT&amp;T-branded). That is the live system of engagement.</a:t>
             </a:r>
           </a:p>
           <a:p>
@@ -3643,7 +3643,7 @@
                 </a:solidFill>
                 <a:latin typeface="Arial"/>
               </a:rPr>
-              <a:t>Why API with it: many AT&amp;T apps will not speak MCP yet; Search/Lookup covers those surfaces with the same live knowledge.</a:t>
+              <a:t>By use case: agents / agent platforms → MCP. Custom apps / backends → API. Neither pipe alone covers every AI project — choose the right one per request.</a:t>
             </a:r>
           </a:p>
           <a:p>
@@ -3659,7 +3659,7 @@
                 </a:solidFill>
                 <a:latin typeface="Arial"/>
               </a:rPr>
-              <a:t>Why domain stays strategic: security already drove a full copy into Ask Docs. That investment is real — and unfinished. Completing it requires golden questions, stewards, and operating cadence before it can rival Insightful’s curated experience.</a:t>
+              <a:t>Separate goal: Ask AT&amp;T domain copy is uploaded for security. Completing it needs golden questions, stewards, and governance before it earns broad trust.</a:t>
             </a:r>
           </a:p>
         </p:txBody>
@@ -10240,7 +10240,7 @@
                 </a:solidFill>
                 <a:latin typeface="Arial"/>
               </a:rPr>
-              <a:t>Approve MCP + API path</a:t>
+              <a:t>Approve MCP or API by use case</a:t>
             </a:r>
           </a:p>
         </p:txBody>
@@ -10275,7 +10275,7 @@
                 </a:solidFill>
                 <a:latin typeface="Arial"/>
               </a:rPr>
-              <a:t>Authorize commercial/security engagement to enable Insightful MCP and API for sanctioned AI projects.</a:t>
+              <a:t>Authorize commercial/security engagement so sanctioned AI projects can get MCP or API access to live Insightful based on need.</a:t>
             </a:r>
           </a:p>
         </p:txBody>
@@ -10425,7 +10425,7 @@
                 </a:solidFill>
                 <a:latin typeface="Arial"/>
               </a:rPr>
-              <a:t>Assign MCP/API owner and interim Knowledge Steward; confirm SME panel.</a:t>
+              <a:t>Assign access owner (MCP/API intake) and interim Knowledge Steward; confirm SME panel.</a:t>
             </a:r>
           </a:p>
         </p:txBody>
@@ -10540,7 +10540,7 @@
                 </a:solidFill>
                 <a:latin typeface="Arial"/>
               </a:rPr>
-              <a:t>Fund domain as side goal</a:t>
+              <a:t>Fund domain as separate goal</a:t>
             </a:r>
           </a:p>
         </p:txBody>
@@ -10575,7 +10575,7 @@
                 </a:solidFill>
                 <a:latin typeface="Arial"/>
               </a:rPr>
-              <a:t>Endorse golden-question stand-up and steward operating model — without blocking agent demand on domain go-live.</a:t>
+              <a:t>Endorse golden-question stand-up and steward model — without blocking demand on domain go-live.</a:t>
             </a:r>
           </a:p>
         </p:txBody>
@@ -10725,7 +10725,7 @@
                 </a:solidFill>
                 <a:latin typeface="Arial"/>
               </a:rPr>
-              <a:t>CMO-backed rules: who gets MCP/API credentials; who gets Ask AT&amp;T domain access; anti-workaround stance.</a:t>
+              <a:t>CMO-backed rules: which use cases get MCP vs API; who gets Ask AT&amp;T domain access; anti-workaround stance.</a:t>
             </a:r>
           </a:p>
         </p:txBody>
@@ -10977,8 +10977,8 @@
                 </a:solidFill>
                 <a:latin typeface="Arial"/>
               </a:rPr>
-              <a:t>Serve demand with MCP + API.
-Build the domain with discipline.</a:t>
+              <a:t>Approve the right pipe by use case.
+Build the domain as its own goal.</a:t>
             </a:r>
           </a:p>
         </p:txBody>
@@ -11013,8 +11013,8 @@
                 </a:solidFill>
                 <a:latin typeface="Arial"/>
               </a:rPr>
-              <a:t>That keeps Insightful’s proprietary advantage working for AT&amp;T’s AI ecosystem —
-and keeps Ask AT&amp;T on a path that is governed, tested, and staffed to last.</a:t>
+              <a:t>Keep content and assistant on live Insightful today — open MCP or API where teams need it —
+and staff Ask AT&amp;T so the copy path is governed, tested, and ready when it earns trust.</a:t>
             </a:r>
           </a:p>
         </p:txBody>
@@ -11166,8 +11166,8 @@
         </p:nvSpPr>
         <p:spPr>
           <a:xfrm>
-            <a:off x="548640" y="365760"/>
-            <a:ext cx="10972800" cy="457200"/>
+            <a:off x="548640" y="320040"/>
+            <a:ext cx="10972800" cy="411480"/>
           </a:xfrm>
           <a:prstGeom prst="rect">
             <a:avLst/>
@@ -11201,8 +11201,8 @@
         </p:nvSpPr>
         <p:spPr>
           <a:xfrm>
-            <a:off x="548640" y="1005840"/>
-            <a:ext cx="10972800" cy="548640"/>
+            <a:off x="548640" y="822960"/>
+            <a:ext cx="10972800" cy="411480"/>
           </a:xfrm>
           <a:prstGeom prst="rect">
             <a:avLst/>
@@ -11217,27 +11217,62 @@
           <a:p>
             <a:pPr algn="l"/>
             <a:r>
-              <a:rPr sz="2000" b="0">
+              <a:rPr sz="1600" b="0">
+                <a:solidFill>
+                  <a:srgbClr val="5A5A5A"/>
+                </a:solidFill>
+                <a:latin typeface="Arial"/>
+              </a:rPr>
+              <a:t>Today, content and the AI assistant live only in Insightful (Stravito, AT&amp;T-branded).</a:t>
+            </a:r>
+          </a:p>
+        </p:txBody>
+      </p:sp>
+      <p:sp>
+        <p:nvSpPr>
+          <p:cNvPr id="6" name="TextBox 5"/>
+          <p:cNvSpPr txBox="1"/>
+          <p:nvPr/>
+        </p:nvSpPr>
+        <p:spPr>
+          <a:xfrm>
+            <a:off x="548640" y="1234440"/>
+            <a:ext cx="10972800" cy="365760"/>
+          </a:xfrm>
+          <a:prstGeom prst="rect">
+            <a:avLst/>
+          </a:prstGeom>
+          <a:noFill/>
+        </p:spPr>
+        <p:txBody>
+          <a:bodyPr wrap="square">
+            <a:spAutoFit/>
+          </a:bodyPr>
+          <a:lstStyle/>
+          <a:p>
+            <a:pPr algn="l"/>
+            <a:r>
+              <a:rPr sz="1800" b="1">
                 <a:solidFill>
                   <a:srgbClr val="000000"/>
                 </a:solidFill>
                 <a:latin typeface="Arial"/>
               </a:rPr>
-              <a:t>Approve a dual-track approach to Insightful AI access.</a:t>
-            </a:r>
-          </a:p>
-        </p:txBody>
-      </p:sp>
-      <p:sp>
-        <p:nvSpPr>
-          <p:cNvPr id="6" name="Rounded Rectangle 5"/>
+              <a:t>Approve MCP or API access by use case. Keep the knowledge domain as a separate goal.</a:t>
+            </a:r>
+          </a:p>
+        </p:txBody>
+      </p:sp>
+      <p:sp>
+        <p:nvSpPr>
+          <p:cNvPr id="7" name="Rounded Rectangle 6"/>
           <p:cNvSpPr/>
           <p:nvPr/>
         </p:nvSpPr>
         <p:spPr>
           <a:xfrm>
-            <a:off x="548640" y="1828800"/>
-            <a:ext cx="5303520" cy="3474720"/>
+            <a:off x="548640" y="1783080"/>
+            <a:ext cx="5303520" cy="3657600"/>
           </a:xfrm>
           <a:prstGeom prst="roundRect">
             <a:avLst>
@@ -11275,14 +11310,14 @@
       </p:sp>
       <p:sp>
         <p:nvSpPr>
-          <p:cNvPr id="7" name="TextBox 6"/>
-          <p:cNvSpPr txBox="1"/>
-          <p:nvPr/>
-        </p:nvSpPr>
-        <p:spPr>
-          <a:xfrm>
-            <a:off x="822960" y="2057400"/>
-            <a:ext cx="4754880" cy="365760"/>
+          <p:cNvPr id="8" name="TextBox 7"/>
+          <p:cNvSpPr txBox="1"/>
+          <p:nvPr/>
+        </p:nvSpPr>
+        <p:spPr>
+          <a:xfrm>
+            <a:off x="822960" y="2011680"/>
+            <a:ext cx="4754880" cy="320040"/>
           </a:xfrm>
           <a:prstGeom prst="rect">
             <a:avLst/>
@@ -11303,21 +11338,21 @@
                 </a:solidFill>
                 <a:latin typeface="Arial"/>
               </a:rPr>
-              <a:t>PRIMARY — NOW</a:t>
-            </a:r>
-          </a:p>
-        </p:txBody>
-      </p:sp>
-      <p:sp>
-        <p:nvSpPr>
-          <p:cNvPr id="8" name="TextBox 7"/>
-          <p:cNvSpPr txBox="1"/>
-          <p:nvPr/>
-        </p:nvSpPr>
-        <p:spPr>
-          <a:xfrm>
-            <a:off x="822960" y="2468880"/>
-            <a:ext cx="4754880" cy="731520"/>
+              <a:t>NEAR-TERM — BY USE CASE</a:t>
+            </a:r>
+          </a:p>
+        </p:txBody>
+      </p:sp>
+      <p:sp>
+        <p:nvSpPr>
+          <p:cNvPr id="9" name="TextBox 8"/>
+          <p:cNvSpPr txBox="1"/>
+          <p:nvPr/>
+        </p:nvSpPr>
+        <p:spPr>
+          <a:xfrm>
+            <a:off x="822960" y="2423160"/>
+            <a:ext cx="4754880" cy="822960"/>
           </a:xfrm>
           <a:prstGeom prst="rect">
             <a:avLst/>
@@ -11332,26 +11367,26 @@
           <a:p>
             <a:pPr algn="l"/>
             <a:r>
-              <a:rPr sz="2200" b="1">
+              <a:rPr sz="2000" b="1">
                 <a:solidFill>
                   <a:srgbClr val="0C2577"/>
                 </a:solidFill>
                 <a:latin typeface="Arial"/>
               </a:rPr>
-              <a:t>Sign on for MCP (preferred) and API</a:t>
-            </a:r>
-          </a:p>
-        </p:txBody>
-      </p:sp>
-      <p:sp>
-        <p:nvSpPr>
-          <p:cNvPr id="9" name="TextBox 8"/>
-          <p:cNvSpPr txBox="1"/>
-          <p:nvPr/>
-        </p:nvSpPr>
-        <p:spPr>
-          <a:xfrm>
-            <a:off x="822960" y="3291840"/>
+              <a:t>Approve MCP or API access to live Insightful</a:t>
+            </a:r>
+          </a:p>
+        </p:txBody>
+      </p:sp>
+      <p:sp>
+        <p:nvSpPr>
+          <p:cNvPr id="10" name="TextBox 9"/>
+          <p:cNvSpPr txBox="1"/>
+          <p:nvPr/>
+        </p:nvSpPr>
+        <p:spPr>
+          <a:xfrm>
+            <a:off x="822960" y="3383280"/>
             <a:ext cx="4754880" cy="1828800"/>
           </a:xfrm>
           <a:prstGeom prst="rect">
@@ -11371,13 +11406,13 @@
               </a:spcAft>
             </a:pPr>
             <a:r>
-              <a:rPr sz="1500" b="0">
+              <a:rPr sz="1400" b="0">
                 <a:solidFill>
                   <a:srgbClr val="5A5A5A"/>
                 </a:solidFill>
                 <a:latin typeface="Arial"/>
               </a:rPr>
-              <a:t>Gives teams building agents and AI-backed tools a governed way to pull Insightful knowledge into their work.</a:t>
+              <a:t>Agents / agent platforms → MCP</a:t>
             </a:r>
           </a:p>
           <a:p>
@@ -11387,27 +11422,43 @@
               </a:spcAft>
             </a:pPr>
             <a:r>
-              <a:rPr sz="1500" b="0">
+              <a:rPr sz="1400" b="0">
                 <a:solidFill>
                   <a:srgbClr val="5A5A5A"/>
                 </a:solidFill>
                 <a:latin typeface="Arial"/>
               </a:rPr>
-              <a:t>Solves immediate demand and reduces shadow integrations.</a:t>
-            </a:r>
-          </a:p>
-        </p:txBody>
-      </p:sp>
-      <p:sp>
-        <p:nvSpPr>
-          <p:cNvPr id="10" name="Rounded Rectangle 9"/>
+              <a:t>Custom apps / backends → API</a:t>
+            </a:r>
+          </a:p>
+          <a:p>
+            <a:pPr>
+              <a:spcAft>
+                <a:spcPts val="800"/>
+              </a:spcAft>
+            </a:pPr>
+            <a:r>
+              <a:rPr sz="1400" b="0">
+                <a:solidFill>
+                  <a:srgbClr val="5A5A5A"/>
+                </a:solidFill>
+                <a:latin typeface="Arial"/>
+              </a:rPr>
+              <a:t>Same live Insightful knowledge. Right pipe for each project. Stops workarounds.</a:t>
+            </a:r>
+          </a:p>
+        </p:txBody>
+      </p:sp>
+      <p:sp>
+        <p:nvSpPr>
+          <p:cNvPr id="11" name="Rounded Rectangle 10"/>
           <p:cNvSpPr/>
           <p:nvPr/>
         </p:nvSpPr>
         <p:spPr>
           <a:xfrm>
-            <a:off x="6217920" y="1828800"/>
-            <a:ext cx="5303520" cy="3474720"/>
+            <a:off x="6217920" y="1783080"/>
+            <a:ext cx="5303520" cy="3657600"/>
           </a:xfrm>
           <a:prstGeom prst="roundRect">
             <a:avLst>
@@ -11445,14 +11496,14 @@
       </p:sp>
       <p:sp>
         <p:nvSpPr>
-          <p:cNvPr id="11" name="TextBox 10"/>
-          <p:cNvSpPr txBox="1"/>
-          <p:nvPr/>
-        </p:nvSpPr>
-        <p:spPr>
-          <a:xfrm>
-            <a:off x="6492240" y="2057400"/>
-            <a:ext cx="4754880" cy="365760"/>
+          <p:cNvPr id="12" name="TextBox 11"/>
+          <p:cNvSpPr txBox="1"/>
+          <p:nvPr/>
+        </p:nvSpPr>
+        <p:spPr>
+          <a:xfrm>
+            <a:off x="6492240" y="2011680"/>
+            <a:ext cx="4754880" cy="320040"/>
           </a:xfrm>
           <a:prstGeom prst="rect">
             <a:avLst/>
@@ -11473,21 +11524,21 @@
                 </a:solidFill>
                 <a:latin typeface="Arial"/>
               </a:rPr>
-              <a:t>STRATEGIC — PARALLEL</a:t>
-            </a:r>
-          </a:p>
-        </p:txBody>
-      </p:sp>
-      <p:sp>
-        <p:nvSpPr>
-          <p:cNvPr id="12" name="TextBox 11"/>
-          <p:cNvSpPr txBox="1"/>
-          <p:nvPr/>
-        </p:nvSpPr>
-        <p:spPr>
-          <a:xfrm>
-            <a:off x="6492240" y="2468880"/>
-            <a:ext cx="4754880" cy="731520"/>
+              <a:t>SEPARATE GOAL</a:t>
+            </a:r>
+          </a:p>
+        </p:txBody>
+      </p:sp>
+      <p:sp>
+        <p:nvSpPr>
+          <p:cNvPr id="13" name="TextBox 12"/>
+          <p:cNvSpPr txBox="1"/>
+          <p:nvPr/>
+        </p:nvSpPr>
+        <p:spPr>
+          <a:xfrm>
+            <a:off x="6492240" y="2423160"/>
+            <a:ext cx="4754880" cy="822960"/>
           </a:xfrm>
           <a:prstGeom prst="rect">
             <a:avLst/>
@@ -11502,7 +11553,7 @@
           <a:p>
             <a:pPr algn="l"/>
             <a:r>
-              <a:rPr sz="2200" b="1">
+              <a:rPr sz="2000" b="1">
                 <a:solidFill>
                   <a:srgbClr val="0C2577"/>
                 </a:solidFill>
@@ -11515,13 +11566,13 @@
       </p:sp>
       <p:sp>
         <p:nvSpPr>
-          <p:cNvPr id="13" name="TextBox 12"/>
-          <p:cNvSpPr txBox="1"/>
-          <p:nvPr/>
-        </p:nvSpPr>
-        <p:spPr>
-          <a:xfrm>
-            <a:off x="6492240" y="3291840"/>
+          <p:cNvPr id="14" name="TextBox 13"/>
+          <p:cNvSpPr txBox="1"/>
+          <p:nvPr/>
+        </p:nvSpPr>
+        <p:spPr>
+          <a:xfrm>
+            <a:off x="6492240" y="3383280"/>
             <a:ext cx="4754880" cy="1828800"/>
           </a:xfrm>
           <a:prstGeom prst="rect">
@@ -11541,13 +11592,13 @@
               </a:spcAft>
             </a:pPr>
             <a:r>
-              <a:rPr sz="1500" b="0">
+              <a:rPr sz="1400" b="0">
                 <a:solidFill>
                   <a:srgbClr val="5A5A5A"/>
                 </a:solidFill>
                 <a:latin typeface="Arial"/>
               </a:rPr>
-              <a:t>Corpus copy + metadata already uploaded for security. Next: golden questions, truth answers, governance, stewards.</a:t>
+              <a:t>Security copy (content + metadata) already uploaded.</a:t>
             </a:r>
           </a:p>
           <a:p>
@@ -11557,20 +11608,36 @@
               </a:spcAft>
             </a:pPr>
             <a:r>
-              <a:rPr sz="1500" b="0">
+              <a:rPr sz="1400" b="0">
                 <a:solidFill>
                   <a:srgbClr val="5A5A5A"/>
                 </a:solidFill>
                 <a:latin typeface="Arial"/>
               </a:rPr>
-              <a:t>Treat as a side goal we invest in — not the near-term demand fix.</a:t>
-            </a:r>
-          </a:p>
-        </p:txBody>
-      </p:sp>
-      <p:sp>
-        <p:nvSpPr>
-          <p:cNvPr id="14" name="TextBox 13"/>
+              <a:t>Next: golden questions, truth answers, governance, stewards.</a:t>
+            </a:r>
+          </a:p>
+          <a:p>
+            <a:pPr>
+              <a:spcAft>
+                <a:spcPts val="800"/>
+              </a:spcAft>
+            </a:pPr>
+            <a:r>
+              <a:rPr sz="1400" b="0">
+                <a:solidFill>
+                  <a:srgbClr val="5A5A5A"/>
+                </a:solidFill>
+                <a:latin typeface="Arial"/>
+              </a:rPr>
+              <a:t>Not the near-term demand fix — its own investment track.</a:t>
+            </a:r>
+          </a:p>
+        </p:txBody>
+      </p:sp>
+      <p:sp>
+        <p:nvSpPr>
+          <p:cNvPr id="15" name="TextBox 14"/>
           <p:cNvSpPr txBox="1"/>
           <p:nvPr/>
         </p:nvSpPr>
@@ -11605,7 +11672,7 @@
       </p:sp>
       <p:sp>
         <p:nvSpPr>
-          <p:cNvPr id="15" name="TextBox 14"/>
+          <p:cNvPr id="16" name="TextBox 15"/>
           <p:cNvSpPr txBox="1"/>
           <p:nvPr/>
         </p:nvSpPr>
@@ -16197,7 +16264,7 @@
                 </a:solidFill>
                 <a:latin typeface="Arial"/>
               </a:rPr>
-              <a:t>MCP  ·  PRIMARY NOW</a:t>
+              <a:t>MCP  ·  BY USE CASE</a:t>
             </a:r>
           </a:p>
         </p:txBody>
@@ -16232,8 +16299,8 @@
                 </a:solidFill>
                 <a:latin typeface="Arial"/>
               </a:rPr>
-              <a:t>Tool calls: search · retrieve · cite
-Live Insightful, agent-native</a:t>
+              <a:t>Agents / agent platforms
+Live Insightful tool calls</a:t>
             </a:r>
           </a:p>
         </p:txBody>
@@ -16315,7 +16382,7 @@
                 </a:solidFill>
                 <a:latin typeface="Arial"/>
               </a:rPr>
-              <a:t>API  ·  COMPANION NOW</a:t>
+              <a:t>API  ·  BY USE CASE</a:t>
             </a:r>
           </a:p>
         </p:txBody>
@@ -16350,8 +16417,8 @@
                 </a:solidFill>
                 <a:latin typeface="Arial"/>
               </a:rPr>
-              <a:t>REST Search / Lookup / logs
-Live Insightful for custom apps</a:t>
+              <a:t>Custom apps / backends
+Live Search / Lookup</a:t>
             </a:r>
           </a:p>
         </p:txBody>
@@ -16433,7 +16500,7 @@
                 </a:solidFill>
                 <a:latin typeface="Arial"/>
               </a:rPr>
-              <a:t>Knowledge domain  ·  SIDE GOAL</a:t>
+              <a:t>Knowledge domain  ·  SEPARATE</a:t>
             </a:r>
           </a:p>
         </p:txBody>
@@ -16468,8 +16535,8 @@
                 </a:solidFill>
                 <a:latin typeface="Arial"/>
               </a:rPr>
-              <a:t>Q&amp;A on secured copy + metadata
-Ask Docs golden-question path</a:t>
+              <a:t>Ask AT&amp;T Q&amp;A on secured copy
+Golden-question quality path</a:t>
             </a:r>
           </a:p>
         </p:txBody>

</xml_diff>

<commit_message>
Add browser HTML viewer for CMO Insightful deck (#2)
* Add browser HTML viewer for CMO Insightful deck

Co-authored-by: ChristophToth <ChristophToth@users.noreply.github.com>

* Align CMO deck to use-case MCP/API recommendation

Update ask, architecture, recommendation, decisions, HTML viewer,
and speaker notes: approve MCP or API by use case; knowledge domain
is a separate goal; content/assistant live only in Insightful today.

Co-authored-by: ChristophToth <ChristophToth@users.noreply.github.com>

---------

Co-authored-by: Cursor Agent <cursoragent@cursor.com>
Co-authored-by: ChristophToth <ChristophToth@users.noreply.github.com>
</commit_message>
<xml_diff>
--- a/presentations/cmo-insightful-ai-access/CMO_Insightful_AI_Access_Recommendation.pptx
+++ b/presentations/cmo-insightful-ai-access/CMO_Insightful_AI_Access_Recommendation.pptx
@@ -3588,7 +3588,7 @@
                 </a:solidFill>
                 <a:latin typeface="Arial"/>
               </a:rPr>
-              <a:t>Sign on for MCP as the primary path for agent builders; enable API alongside it for custom AI tools. Advance the Ask AT&amp;T knowledge domain as a strategic side investment — not the near-term demand solution.</a:t>
+              <a:t>Approve MCP or API access to live Insightful based on use case. Treat the Ask AT&amp;T knowledge domain as a separate goal — not the near-term demand solution.</a:t>
             </a:r>
           </a:p>
         </p:txBody>
@@ -3627,7 +3627,7 @@
                 </a:solidFill>
                 <a:latin typeface="Arial"/>
               </a:rPr>
-              <a:t>Why MCP first for agents: it is the cleanest way for AI tools to call Insightful as a governed capability — search, retrieve, cite — without each team inventing a private pipeline.</a:t>
+              <a:t>Today: content and the AI assistant exist only inside Insightful (Stravito, AT&amp;T-branded). That is the live system of engagement.</a:t>
             </a:r>
           </a:p>
           <a:p>
@@ -3643,7 +3643,7 @@
                 </a:solidFill>
                 <a:latin typeface="Arial"/>
               </a:rPr>
-              <a:t>Why API with it: many AT&amp;T apps will not speak MCP yet; Search/Lookup covers those surfaces with the same live knowledge.</a:t>
+              <a:t>By use case: agents / agent platforms → MCP. Custom apps / backends → API. Neither pipe alone covers every AI project — choose the right one per request.</a:t>
             </a:r>
           </a:p>
           <a:p>
@@ -3659,7 +3659,7 @@
                 </a:solidFill>
                 <a:latin typeface="Arial"/>
               </a:rPr>
-              <a:t>Why domain stays strategic: security already drove a full copy into Ask Docs. That investment is real — and unfinished. Completing it requires golden questions, stewards, and operating cadence before it can rival Insightful’s curated experience.</a:t>
+              <a:t>Separate goal: Ask AT&amp;T domain copy is uploaded for security. Completing it needs golden questions, stewards, and governance before it earns broad trust.</a:t>
             </a:r>
           </a:p>
         </p:txBody>
@@ -10240,7 +10240,7 @@
                 </a:solidFill>
                 <a:latin typeface="Arial"/>
               </a:rPr>
-              <a:t>Approve MCP + API path</a:t>
+              <a:t>Approve MCP or API by use case</a:t>
             </a:r>
           </a:p>
         </p:txBody>
@@ -10275,7 +10275,7 @@
                 </a:solidFill>
                 <a:latin typeface="Arial"/>
               </a:rPr>
-              <a:t>Authorize commercial/security engagement to enable Insightful MCP and API for sanctioned AI projects.</a:t>
+              <a:t>Authorize commercial/security engagement so sanctioned AI projects can get MCP or API access to live Insightful based on need.</a:t>
             </a:r>
           </a:p>
         </p:txBody>
@@ -10425,7 +10425,7 @@
                 </a:solidFill>
                 <a:latin typeface="Arial"/>
               </a:rPr>
-              <a:t>Assign MCP/API owner and interim Knowledge Steward; confirm SME panel.</a:t>
+              <a:t>Assign access owner (MCP/API intake) and interim Knowledge Steward; confirm SME panel.</a:t>
             </a:r>
           </a:p>
         </p:txBody>
@@ -10540,7 +10540,7 @@
                 </a:solidFill>
                 <a:latin typeface="Arial"/>
               </a:rPr>
-              <a:t>Fund domain as side goal</a:t>
+              <a:t>Fund domain as separate goal</a:t>
             </a:r>
           </a:p>
         </p:txBody>
@@ -10575,7 +10575,7 @@
                 </a:solidFill>
                 <a:latin typeface="Arial"/>
               </a:rPr>
-              <a:t>Endorse golden-question stand-up and steward operating model — without blocking agent demand on domain go-live.</a:t>
+              <a:t>Endorse golden-question stand-up and steward model — without blocking demand on domain go-live.</a:t>
             </a:r>
           </a:p>
         </p:txBody>
@@ -10725,7 +10725,7 @@
                 </a:solidFill>
                 <a:latin typeface="Arial"/>
               </a:rPr>
-              <a:t>CMO-backed rules: who gets MCP/API credentials; who gets Ask AT&amp;T domain access; anti-workaround stance.</a:t>
+              <a:t>CMO-backed rules: which use cases get MCP vs API; who gets Ask AT&amp;T domain access; anti-workaround stance.</a:t>
             </a:r>
           </a:p>
         </p:txBody>
@@ -10977,8 +10977,8 @@
                 </a:solidFill>
                 <a:latin typeface="Arial"/>
               </a:rPr>
-              <a:t>Serve demand with MCP + API.
-Build the domain with discipline.</a:t>
+              <a:t>Approve the right pipe by use case.
+Build the domain as its own goal.</a:t>
             </a:r>
           </a:p>
         </p:txBody>
@@ -11013,8 +11013,8 @@
                 </a:solidFill>
                 <a:latin typeface="Arial"/>
               </a:rPr>
-              <a:t>That keeps Insightful’s proprietary advantage working for AT&amp;T’s AI ecosystem —
-and keeps Ask AT&amp;T on a path that is governed, tested, and staffed to last.</a:t>
+              <a:t>Keep content and assistant on live Insightful today — open MCP or API where teams need it —
+and staff Ask AT&amp;T so the copy path is governed, tested, and ready when it earns trust.</a:t>
             </a:r>
           </a:p>
         </p:txBody>
@@ -11166,8 +11166,8 @@
         </p:nvSpPr>
         <p:spPr>
           <a:xfrm>
-            <a:off x="548640" y="365760"/>
-            <a:ext cx="10972800" cy="457200"/>
+            <a:off x="548640" y="320040"/>
+            <a:ext cx="10972800" cy="411480"/>
           </a:xfrm>
           <a:prstGeom prst="rect">
             <a:avLst/>
@@ -11201,8 +11201,8 @@
         </p:nvSpPr>
         <p:spPr>
           <a:xfrm>
-            <a:off x="548640" y="1005840"/>
-            <a:ext cx="10972800" cy="548640"/>
+            <a:off x="548640" y="822960"/>
+            <a:ext cx="10972800" cy="411480"/>
           </a:xfrm>
           <a:prstGeom prst="rect">
             <a:avLst/>
@@ -11217,27 +11217,62 @@
           <a:p>
             <a:pPr algn="l"/>
             <a:r>
-              <a:rPr sz="2000" b="0">
+              <a:rPr sz="1600" b="0">
+                <a:solidFill>
+                  <a:srgbClr val="5A5A5A"/>
+                </a:solidFill>
+                <a:latin typeface="Arial"/>
+              </a:rPr>
+              <a:t>Today, content and the AI assistant live only in Insightful (Stravito, AT&amp;T-branded).</a:t>
+            </a:r>
+          </a:p>
+        </p:txBody>
+      </p:sp>
+      <p:sp>
+        <p:nvSpPr>
+          <p:cNvPr id="6" name="TextBox 5"/>
+          <p:cNvSpPr txBox="1"/>
+          <p:nvPr/>
+        </p:nvSpPr>
+        <p:spPr>
+          <a:xfrm>
+            <a:off x="548640" y="1234440"/>
+            <a:ext cx="10972800" cy="365760"/>
+          </a:xfrm>
+          <a:prstGeom prst="rect">
+            <a:avLst/>
+          </a:prstGeom>
+          <a:noFill/>
+        </p:spPr>
+        <p:txBody>
+          <a:bodyPr wrap="square">
+            <a:spAutoFit/>
+          </a:bodyPr>
+          <a:lstStyle/>
+          <a:p>
+            <a:pPr algn="l"/>
+            <a:r>
+              <a:rPr sz="1800" b="1">
                 <a:solidFill>
                   <a:srgbClr val="000000"/>
                 </a:solidFill>
                 <a:latin typeface="Arial"/>
               </a:rPr>
-              <a:t>Approve a dual-track approach to Insightful AI access.</a:t>
-            </a:r>
-          </a:p>
-        </p:txBody>
-      </p:sp>
-      <p:sp>
-        <p:nvSpPr>
-          <p:cNvPr id="6" name="Rounded Rectangle 5"/>
+              <a:t>Approve MCP or API access by use case. Keep the knowledge domain as a separate goal.</a:t>
+            </a:r>
+          </a:p>
+        </p:txBody>
+      </p:sp>
+      <p:sp>
+        <p:nvSpPr>
+          <p:cNvPr id="7" name="Rounded Rectangle 6"/>
           <p:cNvSpPr/>
           <p:nvPr/>
         </p:nvSpPr>
         <p:spPr>
           <a:xfrm>
-            <a:off x="548640" y="1828800"/>
-            <a:ext cx="5303520" cy="3474720"/>
+            <a:off x="548640" y="1783080"/>
+            <a:ext cx="5303520" cy="3657600"/>
           </a:xfrm>
           <a:prstGeom prst="roundRect">
             <a:avLst>
@@ -11275,14 +11310,14 @@
       </p:sp>
       <p:sp>
         <p:nvSpPr>
-          <p:cNvPr id="7" name="TextBox 6"/>
-          <p:cNvSpPr txBox="1"/>
-          <p:nvPr/>
-        </p:nvSpPr>
-        <p:spPr>
-          <a:xfrm>
-            <a:off x="822960" y="2057400"/>
-            <a:ext cx="4754880" cy="365760"/>
+          <p:cNvPr id="8" name="TextBox 7"/>
+          <p:cNvSpPr txBox="1"/>
+          <p:nvPr/>
+        </p:nvSpPr>
+        <p:spPr>
+          <a:xfrm>
+            <a:off x="822960" y="2011680"/>
+            <a:ext cx="4754880" cy="320040"/>
           </a:xfrm>
           <a:prstGeom prst="rect">
             <a:avLst/>
@@ -11303,21 +11338,21 @@
                 </a:solidFill>
                 <a:latin typeface="Arial"/>
               </a:rPr>
-              <a:t>PRIMARY — NOW</a:t>
-            </a:r>
-          </a:p>
-        </p:txBody>
-      </p:sp>
-      <p:sp>
-        <p:nvSpPr>
-          <p:cNvPr id="8" name="TextBox 7"/>
-          <p:cNvSpPr txBox="1"/>
-          <p:nvPr/>
-        </p:nvSpPr>
-        <p:spPr>
-          <a:xfrm>
-            <a:off x="822960" y="2468880"/>
-            <a:ext cx="4754880" cy="731520"/>
+              <a:t>NEAR-TERM — BY USE CASE</a:t>
+            </a:r>
+          </a:p>
+        </p:txBody>
+      </p:sp>
+      <p:sp>
+        <p:nvSpPr>
+          <p:cNvPr id="9" name="TextBox 8"/>
+          <p:cNvSpPr txBox="1"/>
+          <p:nvPr/>
+        </p:nvSpPr>
+        <p:spPr>
+          <a:xfrm>
+            <a:off x="822960" y="2423160"/>
+            <a:ext cx="4754880" cy="822960"/>
           </a:xfrm>
           <a:prstGeom prst="rect">
             <a:avLst/>
@@ -11332,26 +11367,26 @@
           <a:p>
             <a:pPr algn="l"/>
             <a:r>
-              <a:rPr sz="2200" b="1">
+              <a:rPr sz="2000" b="1">
                 <a:solidFill>
                   <a:srgbClr val="0C2577"/>
                 </a:solidFill>
                 <a:latin typeface="Arial"/>
               </a:rPr>
-              <a:t>Sign on for MCP (preferred) and API</a:t>
-            </a:r>
-          </a:p>
-        </p:txBody>
-      </p:sp>
-      <p:sp>
-        <p:nvSpPr>
-          <p:cNvPr id="9" name="TextBox 8"/>
-          <p:cNvSpPr txBox="1"/>
-          <p:nvPr/>
-        </p:nvSpPr>
-        <p:spPr>
-          <a:xfrm>
-            <a:off x="822960" y="3291840"/>
+              <a:t>Approve MCP or API access to live Insightful</a:t>
+            </a:r>
+          </a:p>
+        </p:txBody>
+      </p:sp>
+      <p:sp>
+        <p:nvSpPr>
+          <p:cNvPr id="10" name="TextBox 9"/>
+          <p:cNvSpPr txBox="1"/>
+          <p:nvPr/>
+        </p:nvSpPr>
+        <p:spPr>
+          <a:xfrm>
+            <a:off x="822960" y="3383280"/>
             <a:ext cx="4754880" cy="1828800"/>
           </a:xfrm>
           <a:prstGeom prst="rect">
@@ -11371,13 +11406,13 @@
               </a:spcAft>
             </a:pPr>
             <a:r>
-              <a:rPr sz="1500" b="0">
+              <a:rPr sz="1400" b="0">
                 <a:solidFill>
                   <a:srgbClr val="5A5A5A"/>
                 </a:solidFill>
                 <a:latin typeface="Arial"/>
               </a:rPr>
-              <a:t>Gives teams building agents and AI-backed tools a governed way to pull Insightful knowledge into their work.</a:t>
+              <a:t>Agents / agent platforms → MCP</a:t>
             </a:r>
           </a:p>
           <a:p>
@@ -11387,27 +11422,43 @@
               </a:spcAft>
             </a:pPr>
             <a:r>
-              <a:rPr sz="1500" b="0">
+              <a:rPr sz="1400" b="0">
                 <a:solidFill>
                   <a:srgbClr val="5A5A5A"/>
                 </a:solidFill>
                 <a:latin typeface="Arial"/>
               </a:rPr>
-              <a:t>Solves immediate demand and reduces shadow integrations.</a:t>
-            </a:r>
-          </a:p>
-        </p:txBody>
-      </p:sp>
-      <p:sp>
-        <p:nvSpPr>
-          <p:cNvPr id="10" name="Rounded Rectangle 9"/>
+              <a:t>Custom apps / backends → API</a:t>
+            </a:r>
+          </a:p>
+          <a:p>
+            <a:pPr>
+              <a:spcAft>
+                <a:spcPts val="800"/>
+              </a:spcAft>
+            </a:pPr>
+            <a:r>
+              <a:rPr sz="1400" b="0">
+                <a:solidFill>
+                  <a:srgbClr val="5A5A5A"/>
+                </a:solidFill>
+                <a:latin typeface="Arial"/>
+              </a:rPr>
+              <a:t>Same live Insightful knowledge. Right pipe for each project. Stops workarounds.</a:t>
+            </a:r>
+          </a:p>
+        </p:txBody>
+      </p:sp>
+      <p:sp>
+        <p:nvSpPr>
+          <p:cNvPr id="11" name="Rounded Rectangle 10"/>
           <p:cNvSpPr/>
           <p:nvPr/>
         </p:nvSpPr>
         <p:spPr>
           <a:xfrm>
-            <a:off x="6217920" y="1828800"/>
-            <a:ext cx="5303520" cy="3474720"/>
+            <a:off x="6217920" y="1783080"/>
+            <a:ext cx="5303520" cy="3657600"/>
           </a:xfrm>
           <a:prstGeom prst="roundRect">
             <a:avLst>
@@ -11445,14 +11496,14 @@
       </p:sp>
       <p:sp>
         <p:nvSpPr>
-          <p:cNvPr id="11" name="TextBox 10"/>
-          <p:cNvSpPr txBox="1"/>
-          <p:nvPr/>
-        </p:nvSpPr>
-        <p:spPr>
-          <a:xfrm>
-            <a:off x="6492240" y="2057400"/>
-            <a:ext cx="4754880" cy="365760"/>
+          <p:cNvPr id="12" name="TextBox 11"/>
+          <p:cNvSpPr txBox="1"/>
+          <p:nvPr/>
+        </p:nvSpPr>
+        <p:spPr>
+          <a:xfrm>
+            <a:off x="6492240" y="2011680"/>
+            <a:ext cx="4754880" cy="320040"/>
           </a:xfrm>
           <a:prstGeom prst="rect">
             <a:avLst/>
@@ -11473,21 +11524,21 @@
                 </a:solidFill>
                 <a:latin typeface="Arial"/>
               </a:rPr>
-              <a:t>STRATEGIC — PARALLEL</a:t>
-            </a:r>
-          </a:p>
-        </p:txBody>
-      </p:sp>
-      <p:sp>
-        <p:nvSpPr>
-          <p:cNvPr id="12" name="TextBox 11"/>
-          <p:cNvSpPr txBox="1"/>
-          <p:nvPr/>
-        </p:nvSpPr>
-        <p:spPr>
-          <a:xfrm>
-            <a:off x="6492240" y="2468880"/>
-            <a:ext cx="4754880" cy="731520"/>
+              <a:t>SEPARATE GOAL</a:t>
+            </a:r>
+          </a:p>
+        </p:txBody>
+      </p:sp>
+      <p:sp>
+        <p:nvSpPr>
+          <p:cNvPr id="13" name="TextBox 12"/>
+          <p:cNvSpPr txBox="1"/>
+          <p:nvPr/>
+        </p:nvSpPr>
+        <p:spPr>
+          <a:xfrm>
+            <a:off x="6492240" y="2423160"/>
+            <a:ext cx="4754880" cy="822960"/>
           </a:xfrm>
           <a:prstGeom prst="rect">
             <a:avLst/>
@@ -11502,7 +11553,7 @@
           <a:p>
             <a:pPr algn="l"/>
             <a:r>
-              <a:rPr sz="2200" b="1">
+              <a:rPr sz="2000" b="1">
                 <a:solidFill>
                   <a:srgbClr val="0C2577"/>
                 </a:solidFill>
@@ -11515,13 +11566,13 @@
       </p:sp>
       <p:sp>
         <p:nvSpPr>
-          <p:cNvPr id="13" name="TextBox 12"/>
-          <p:cNvSpPr txBox="1"/>
-          <p:nvPr/>
-        </p:nvSpPr>
-        <p:spPr>
-          <a:xfrm>
-            <a:off x="6492240" y="3291840"/>
+          <p:cNvPr id="14" name="TextBox 13"/>
+          <p:cNvSpPr txBox="1"/>
+          <p:nvPr/>
+        </p:nvSpPr>
+        <p:spPr>
+          <a:xfrm>
+            <a:off x="6492240" y="3383280"/>
             <a:ext cx="4754880" cy="1828800"/>
           </a:xfrm>
           <a:prstGeom prst="rect">
@@ -11541,13 +11592,13 @@
               </a:spcAft>
             </a:pPr>
             <a:r>
-              <a:rPr sz="1500" b="0">
+              <a:rPr sz="1400" b="0">
                 <a:solidFill>
                   <a:srgbClr val="5A5A5A"/>
                 </a:solidFill>
                 <a:latin typeface="Arial"/>
               </a:rPr>
-              <a:t>Corpus copy + metadata already uploaded for security. Next: golden questions, truth answers, governance, stewards.</a:t>
+              <a:t>Security copy (content + metadata) already uploaded.</a:t>
             </a:r>
           </a:p>
           <a:p>
@@ -11557,20 +11608,36 @@
               </a:spcAft>
             </a:pPr>
             <a:r>
-              <a:rPr sz="1500" b="0">
+              <a:rPr sz="1400" b="0">
                 <a:solidFill>
                   <a:srgbClr val="5A5A5A"/>
                 </a:solidFill>
                 <a:latin typeface="Arial"/>
               </a:rPr>
-              <a:t>Treat as a side goal we invest in — not the near-term demand fix.</a:t>
-            </a:r>
-          </a:p>
-        </p:txBody>
-      </p:sp>
-      <p:sp>
-        <p:nvSpPr>
-          <p:cNvPr id="14" name="TextBox 13"/>
+              <a:t>Next: golden questions, truth answers, governance, stewards.</a:t>
+            </a:r>
+          </a:p>
+          <a:p>
+            <a:pPr>
+              <a:spcAft>
+                <a:spcPts val="800"/>
+              </a:spcAft>
+            </a:pPr>
+            <a:r>
+              <a:rPr sz="1400" b="0">
+                <a:solidFill>
+                  <a:srgbClr val="5A5A5A"/>
+                </a:solidFill>
+                <a:latin typeface="Arial"/>
+              </a:rPr>
+              <a:t>Not the near-term demand fix — its own investment track.</a:t>
+            </a:r>
+          </a:p>
+        </p:txBody>
+      </p:sp>
+      <p:sp>
+        <p:nvSpPr>
+          <p:cNvPr id="15" name="TextBox 14"/>
           <p:cNvSpPr txBox="1"/>
           <p:nvPr/>
         </p:nvSpPr>
@@ -11605,7 +11672,7 @@
       </p:sp>
       <p:sp>
         <p:nvSpPr>
-          <p:cNvPr id="15" name="TextBox 14"/>
+          <p:cNvPr id="16" name="TextBox 15"/>
           <p:cNvSpPr txBox="1"/>
           <p:nvPr/>
         </p:nvSpPr>
@@ -16197,7 +16264,7 @@
                 </a:solidFill>
                 <a:latin typeface="Arial"/>
               </a:rPr>
-              <a:t>MCP  ·  PRIMARY NOW</a:t>
+              <a:t>MCP  ·  BY USE CASE</a:t>
             </a:r>
           </a:p>
         </p:txBody>
@@ -16232,8 +16299,8 @@
                 </a:solidFill>
                 <a:latin typeface="Arial"/>
               </a:rPr>
-              <a:t>Tool calls: search · retrieve · cite
-Live Insightful, agent-native</a:t>
+              <a:t>Agents / agent platforms
+Live Insightful tool calls</a:t>
             </a:r>
           </a:p>
         </p:txBody>
@@ -16315,7 +16382,7 @@
                 </a:solidFill>
                 <a:latin typeface="Arial"/>
               </a:rPr>
-              <a:t>API  ·  COMPANION NOW</a:t>
+              <a:t>API  ·  BY USE CASE</a:t>
             </a:r>
           </a:p>
         </p:txBody>
@@ -16350,8 +16417,8 @@
                 </a:solidFill>
                 <a:latin typeface="Arial"/>
               </a:rPr>
-              <a:t>REST Search / Lookup / logs
-Live Insightful for custom apps</a:t>
+              <a:t>Custom apps / backends
+Live Search / Lookup</a:t>
             </a:r>
           </a:p>
         </p:txBody>
@@ -16433,7 +16500,7 @@
                 </a:solidFill>
                 <a:latin typeface="Arial"/>
               </a:rPr>
-              <a:t>Knowledge domain  ·  SIDE GOAL</a:t>
+              <a:t>Knowledge domain  ·  SEPARATE</a:t>
             </a:r>
           </a:p>
         </p:txBody>
@@ -16468,8 +16535,8 @@
                 </a:solidFill>
                 <a:latin typeface="Arial"/>
               </a:rPr>
-              <a:t>Q&amp;A on secured copy + metadata
-Ask Docs golden-question path</a:t>
+              <a:t>Ask AT&amp;T Q&amp;A on secured copy
+Golden-question quality path</a:t>
             </a:r>
           </a:p>
         </p:txBody>

</xml_diff>